<commit_message>
Update schedule and add youtube video
</commit_message>
<xml_diff>
--- a/images/Schedule2026.pptx
+++ b/images/Schedule2026.pptx
@@ -104,6 +104,11 @@
       </a:defRPr>
     </a:lvl9pPr>
   </p:defaultTextStyle>
+  <p:extLst>
+    <p:ext uri="{EFAFB233-063F-42B5-8137-9DF3F51BA10A}">
+      <p15:sldGuideLst xmlns:p15="http://schemas.microsoft.com/office/powerpoint/2012/main"/>
+    </p:ext>
+  </p:extLst>
 </p:presentation>
 </file>
 
@@ -238,7 +243,7 @@
           <a:p>
             <a:fld id="{339A59C9-6208-4201-B378-D03CB4B43504}" type="datetimeFigureOut">
               <a:rPr lang="en-US" smtClean="0"/>
-              <a:t>1/8/2026</a:t>
+              <a:t>1/9/2026</a:t>
             </a:fld>
             <a:endParaRPr lang="en-US"/>
           </a:p>
@@ -408,7 +413,7 @@
           <a:p>
             <a:fld id="{339A59C9-6208-4201-B378-D03CB4B43504}" type="datetimeFigureOut">
               <a:rPr lang="en-US" smtClean="0"/>
-              <a:t>1/8/2026</a:t>
+              <a:t>1/9/2026</a:t>
             </a:fld>
             <a:endParaRPr lang="en-US"/>
           </a:p>
@@ -588,7 +593,7 @@
           <a:p>
             <a:fld id="{339A59C9-6208-4201-B378-D03CB4B43504}" type="datetimeFigureOut">
               <a:rPr lang="en-US" smtClean="0"/>
-              <a:t>1/8/2026</a:t>
+              <a:t>1/9/2026</a:t>
             </a:fld>
             <a:endParaRPr lang="en-US"/>
           </a:p>
@@ -758,7 +763,7 @@
           <a:p>
             <a:fld id="{339A59C9-6208-4201-B378-D03CB4B43504}" type="datetimeFigureOut">
               <a:rPr lang="en-US" smtClean="0"/>
-              <a:t>1/8/2026</a:t>
+              <a:t>1/9/2026</a:t>
             </a:fld>
             <a:endParaRPr lang="en-US"/>
           </a:p>
@@ -1004,7 +1009,7 @@
           <a:p>
             <a:fld id="{339A59C9-6208-4201-B378-D03CB4B43504}" type="datetimeFigureOut">
               <a:rPr lang="en-US" smtClean="0"/>
-              <a:t>1/8/2026</a:t>
+              <a:t>1/9/2026</a:t>
             </a:fld>
             <a:endParaRPr lang="en-US"/>
           </a:p>
@@ -1236,7 +1241,7 @@
           <a:p>
             <a:fld id="{339A59C9-6208-4201-B378-D03CB4B43504}" type="datetimeFigureOut">
               <a:rPr lang="en-US" smtClean="0"/>
-              <a:t>1/8/2026</a:t>
+              <a:t>1/9/2026</a:t>
             </a:fld>
             <a:endParaRPr lang="en-US"/>
           </a:p>
@@ -1603,7 +1608,7 @@
           <a:p>
             <a:fld id="{339A59C9-6208-4201-B378-D03CB4B43504}" type="datetimeFigureOut">
               <a:rPr lang="en-US" smtClean="0"/>
-              <a:t>1/8/2026</a:t>
+              <a:t>1/9/2026</a:t>
             </a:fld>
             <a:endParaRPr lang="en-US"/>
           </a:p>
@@ -1721,7 +1726,7 @@
           <a:p>
             <a:fld id="{339A59C9-6208-4201-B378-D03CB4B43504}" type="datetimeFigureOut">
               <a:rPr lang="en-US" smtClean="0"/>
-              <a:t>1/8/2026</a:t>
+              <a:t>1/9/2026</a:t>
             </a:fld>
             <a:endParaRPr lang="en-US"/>
           </a:p>
@@ -1816,7 +1821,7 @@
           <a:p>
             <a:fld id="{339A59C9-6208-4201-B378-D03CB4B43504}" type="datetimeFigureOut">
               <a:rPr lang="en-US" smtClean="0"/>
-              <a:t>1/8/2026</a:t>
+              <a:t>1/9/2026</a:t>
             </a:fld>
             <a:endParaRPr lang="en-US"/>
           </a:p>
@@ -2093,7 +2098,7 @@
           <a:p>
             <a:fld id="{339A59C9-6208-4201-B378-D03CB4B43504}" type="datetimeFigureOut">
               <a:rPr lang="en-US" smtClean="0"/>
-              <a:t>1/8/2026</a:t>
+              <a:t>1/9/2026</a:t>
             </a:fld>
             <a:endParaRPr lang="en-US"/>
           </a:p>
@@ -2350,7 +2355,7 @@
           <a:p>
             <a:fld id="{339A59C9-6208-4201-B378-D03CB4B43504}" type="datetimeFigureOut">
               <a:rPr lang="en-US" smtClean="0"/>
-              <a:t>1/8/2026</a:t>
+              <a:t>1/9/2026</a:t>
             </a:fld>
             <a:endParaRPr lang="en-US"/>
           </a:p>
@@ -2563,7 +2568,7 @@
           <a:p>
             <a:fld id="{339A59C9-6208-4201-B378-D03CB4B43504}" type="datetimeFigureOut">
               <a:rPr lang="en-US" smtClean="0"/>
-              <a:t>1/8/2026</a:t>
+              <a:t>1/9/2026</a:t>
             </a:fld>
             <a:endParaRPr lang="en-US"/>
           </a:p>
@@ -2983,14 +2988,14 @@
           <p:nvPr>
             <p:extLst>
               <p:ext uri="{D42A27DB-BD31-4B8C-83A1-F6EECF244321}">
-                <p14:modId xmlns:p14="http://schemas.microsoft.com/office/powerpoint/2010/main" val="1517980837"/>
+                <p14:modId xmlns:p14="http://schemas.microsoft.com/office/powerpoint/2010/main" val="2528203865"/>
               </p:ext>
             </p:extLst>
           </p:nvPr>
         </p:nvGraphicFramePr>
         <p:xfrm>
           <a:off x="55613" y="131391"/>
-          <a:ext cx="12080783" cy="7205482"/>
+          <a:ext cx="12023498" cy="7097280"/>
         </p:xfrm>
         <a:graphic>
           <a:graphicData uri="http://schemas.openxmlformats.org/drawingml/2006/table">
@@ -2999,73 +3004,59 @@
                 <a:tableStyleId>{69012ECD-51FC-41F1-AA8D-1B2483CD663E}</a:tableStyleId>
               </a:tblPr>
               <a:tblGrid>
-                <a:gridCol w="828307">
+                <a:gridCol w="816890">
                   <a:extLst>
                     <a:ext uri="{9D8B030D-6E8A-4147-A177-3AD203B41FA5}">
                       <a16:colId xmlns:a16="http://schemas.microsoft.com/office/drawing/2014/main" val="1440251456"/>
                     </a:ext>
                   </a:extLst>
                 </a:gridCol>
-                <a:gridCol w="1219200">
+                <a:gridCol w="1202395">
                   <a:extLst>
                     <a:ext uri="{9D8B030D-6E8A-4147-A177-3AD203B41FA5}">
                       <a16:colId xmlns:a16="http://schemas.microsoft.com/office/drawing/2014/main" val="4062505180"/>
                     </a:ext>
                   </a:extLst>
                 </a:gridCol>
-                <a:gridCol w="1219200">
+                <a:gridCol w="1202395">
                   <a:extLst>
                     <a:ext uri="{9D8B030D-6E8A-4147-A177-3AD203B41FA5}">
                       <a16:colId xmlns:a16="http://schemas.microsoft.com/office/drawing/2014/main" val="3357933269"/>
                     </a:ext>
                   </a:extLst>
                 </a:gridCol>
-                <a:gridCol w="1330960">
+                <a:gridCol w="1312615">
                   <a:extLst>
                     <a:ext uri="{9D8B030D-6E8A-4147-A177-3AD203B41FA5}">
                       <a16:colId xmlns:a16="http://schemas.microsoft.com/office/drawing/2014/main" val="3819861827"/>
                     </a:ext>
                   </a:extLst>
                 </a:gridCol>
-                <a:gridCol w="1524000">
+                <a:gridCol w="1502993">
                   <a:extLst>
                     <a:ext uri="{9D8B030D-6E8A-4147-A177-3AD203B41FA5}">
                       <a16:colId xmlns:a16="http://schemas.microsoft.com/office/drawing/2014/main" val="4122292344"/>
                     </a:ext>
                   </a:extLst>
                 </a:gridCol>
-                <a:gridCol w="2245360">
+                <a:gridCol w="2214411">
                   <a:extLst>
                     <a:ext uri="{9D8B030D-6E8A-4147-A177-3AD203B41FA5}">
                       <a16:colId xmlns:a16="http://schemas.microsoft.com/office/drawing/2014/main" val="1031920213"/>
                     </a:ext>
                   </a:extLst>
                 </a:gridCol>
-                <a:gridCol w="1168400">
+                <a:gridCol w="1948851">
                   <a:extLst>
                     <a:ext uri="{9D8B030D-6E8A-4147-A177-3AD203B41FA5}">
                       <a16:colId xmlns:a16="http://schemas.microsoft.com/office/drawing/2014/main" val="2274626327"/>
                     </a:ext>
                   </a:extLst>
                 </a:gridCol>
-                <a:gridCol w="696930">
-                  <a:extLst>
-                    <a:ext uri="{9D8B030D-6E8A-4147-A177-3AD203B41FA5}">
-                      <a16:colId xmlns:a16="http://schemas.microsoft.com/office/drawing/2014/main" val="2409741768"/>
-                    </a:ext>
-                  </a:extLst>
-                </a:gridCol>
-                <a:gridCol w="616142">
+                <a:gridCol w="1822948">
                   <a:extLst>
                     <a:ext uri="{9D8B030D-6E8A-4147-A177-3AD203B41FA5}">
                       <a16:colId xmlns:a16="http://schemas.microsoft.com/office/drawing/2014/main" val="2568106431"/>
-                    </a:ext>
-                  </a:extLst>
-                </a:gridCol>
-                <a:gridCol w="1232284">
-                  <a:extLst>
-                    <a:ext uri="{9D8B030D-6E8A-4147-A177-3AD203B41FA5}">
-                      <a16:colId xmlns:a16="http://schemas.microsoft.com/office/drawing/2014/main" val="12738670"/>
                     </a:ext>
                   </a:extLst>
                 </a:gridCol>
@@ -3263,7 +3254,7 @@
                   </a:txBody>
                   <a:tcPr/>
                 </a:tc>
-                <a:tc gridSpan="4">
+                <a:tc gridSpan="2">
                   <a:txBody>
                     <a:bodyPr/>
                     <a:lstStyle/>
@@ -3325,27 +3316,17 @@
                       <a:endParaRPr lang="en-US"/>
                     </a:p>
                   </a:txBody>
-                  <a:tcPr/>
-                </a:tc>
-                <a:tc hMerge="1">
-                  <a:txBody>
-                    <a:bodyPr/>
-                    <a:lstStyle/>
-                    <a:p>
-                      <a:endParaRPr lang="en-US"/>
-                    </a:p>
-                  </a:txBody>
-                  <a:tcPr/>
-                </a:tc>
-                <a:tc hMerge="1">
-                  <a:txBody>
-                    <a:bodyPr/>
-                    <a:lstStyle/>
-                    <a:p>
-                      <a:endParaRPr lang="en-US"/>
-                    </a:p>
-                  </a:txBody>
-                  <a:tcPr/>
+                  <a:tcPr>
+                    <a:lnL w="12700" cap="flat" cmpd="sng" algn="ctr">
+                      <a:solidFill>
+                        <a:schemeClr val="accent1"/>
+                      </a:solidFill>
+                      <a:prstDash val="solid"/>
+                      <a:round/>
+                      <a:headEnd type="none" w="med" len="med"/>
+                      <a:tailEnd type="none" w="med" len="med"/>
+                    </a:lnL>
+                  </a:tcPr>
                 </a:tc>
                 <a:extLst>
                   <a:ext uri="{0D108BD9-81ED-4DB2-BD59-A6C34878D82A}">
@@ -3543,7 +3524,7 @@
                   </a:txBody>
                   <a:tcPr/>
                 </a:tc>
-                <a:tc gridSpan="4">
+                <a:tc gridSpan="2">
                   <a:txBody>
                     <a:bodyPr/>
                     <a:lstStyle/>
@@ -3602,27 +3583,17 @@
                       <a:endParaRPr lang="en-US"/>
                     </a:p>
                   </a:txBody>
-                  <a:tcPr/>
-                </a:tc>
-                <a:tc hMerge="1">
-                  <a:txBody>
-                    <a:bodyPr/>
-                    <a:lstStyle/>
-                    <a:p>
-                      <a:endParaRPr lang="en-US"/>
-                    </a:p>
-                  </a:txBody>
-                  <a:tcPr/>
-                </a:tc>
-                <a:tc hMerge="1">
-                  <a:txBody>
-                    <a:bodyPr/>
-                    <a:lstStyle/>
-                    <a:p>
-                      <a:endParaRPr lang="en-US"/>
-                    </a:p>
-                  </a:txBody>
-                  <a:tcPr/>
+                  <a:tcPr>
+                    <a:lnL w="12700" cap="flat" cmpd="sng" algn="ctr">
+                      <a:solidFill>
+                        <a:schemeClr val="accent1"/>
+                      </a:solidFill>
+                      <a:prstDash val="solid"/>
+                      <a:round/>
+                      <a:headEnd type="none" w="med" len="med"/>
+                      <a:tailEnd type="none" w="med" len="med"/>
+                    </a:lnL>
+                  </a:tcPr>
                 </a:tc>
                 <a:extLst>
                   <a:ext uri="{0D108BD9-81ED-4DB2-BD59-A6C34878D82A}">
@@ -3841,7 +3812,7 @@
                   </a:txBody>
                   <a:tcPr/>
                 </a:tc>
-                <a:tc gridSpan="4">
+                <a:tc gridSpan="2">
                   <a:txBody>
                     <a:bodyPr/>
                     <a:lstStyle/>
@@ -3905,27 +3876,17 @@
                       <a:endParaRPr lang="en-US"/>
                     </a:p>
                   </a:txBody>
-                  <a:tcPr/>
-                </a:tc>
-                <a:tc hMerge="1">
-                  <a:txBody>
-                    <a:bodyPr/>
-                    <a:lstStyle/>
-                    <a:p>
-                      <a:endParaRPr lang="en-US"/>
-                    </a:p>
-                  </a:txBody>
-                  <a:tcPr/>
-                </a:tc>
-                <a:tc hMerge="1">
-                  <a:txBody>
-                    <a:bodyPr/>
-                    <a:lstStyle/>
-                    <a:p>
-                      <a:endParaRPr lang="en-US"/>
-                    </a:p>
-                  </a:txBody>
-                  <a:tcPr/>
+                  <a:tcPr>
+                    <a:lnL w="12700" cap="flat" cmpd="sng" algn="ctr">
+                      <a:solidFill>
+                        <a:schemeClr val="accent1"/>
+                      </a:solidFill>
+                      <a:prstDash val="solid"/>
+                      <a:round/>
+                      <a:headEnd type="none" w="med" len="med"/>
+                      <a:tailEnd type="none" w="med" len="med"/>
+                    </a:lnL>
+                  </a:tcPr>
                 </a:tc>
                 <a:extLst>
                   <a:ext uri="{0D108BD9-81ED-4DB2-BD59-A6C34878D82A}">
@@ -4042,23 +4003,19 @@
                   </a:txBody>
                   <a:tcPr/>
                 </a:tc>
-                <a:tc rowSpan="4" gridSpan="4">
+                <a:tc rowSpan="4">
                   <a:txBody>
                     <a:bodyPr/>
                     <a:lstStyle/>
                     <a:p>
                       <a:pPr algn="ctr"/>
                       <a:r>
-                        <a:rPr lang="en-US" sz="1200">
+                        <a:rPr lang="en-US" sz="1200" dirty="0">
                           <a:latin typeface="Arial" panose="020B0604020202020204" pitchFamily="34" charset="0"/>
                           <a:cs typeface="Arial" panose="020B0604020202020204" pitchFamily="34" charset="0"/>
                         </a:rPr>
                         <a:t>Open Hacking</a:t>
                       </a:r>
-                      <a:endParaRPr lang="en-US" sz="1200" dirty="0">
-                        <a:latin typeface="Arial" panose="020B0604020202020204" pitchFamily="34" charset="0"/>
-                        <a:cs typeface="Arial" panose="020B0604020202020204" pitchFamily="34" charset="0"/>
-                      </a:endParaRPr>
                     </a:p>
                   </a:txBody>
                   <a:tcPr marL="93811" marR="93811" marT="46906" marB="46906" anchor="ctr">
@@ -4104,54 +4061,43 @@
                     </a:lnB>
                   </a:tcPr>
                 </a:tc>
-                <a:tc rowSpan="4" hMerge="1">
-                  <a:txBody>
-                    <a:bodyPr/>
-                    <a:lstStyle/>
-                    <a:p>
-                      <a:endParaRPr lang="en-US" sz="1200" dirty="0">
-                        <a:latin typeface="Arial" panose="020B0604020202020204" pitchFamily="34" charset="0"/>
-                        <a:cs typeface="Arial" panose="020B0604020202020204" pitchFamily="34" charset="0"/>
-                      </a:endParaRPr>
-                    </a:p>
-                  </a:txBody>
-                  <a:tcPr marL="93811" marR="93811" marT="46906" marB="46906" anchor="ctr">
-                    <a:lnL w="12700" cap="flat" cmpd="sng" algn="ctr">
-                      <a:solidFill>
-                        <a:schemeClr val="accent1"/>
-                      </a:solidFill>
-                      <a:prstDash val="solid"/>
-                      <a:round/>
-                      <a:headEnd type="none" w="med" len="med"/>
-                      <a:tailEnd type="none" w="med" len="med"/>
-                    </a:lnL>
-                    <a:lnB w="12700" cap="flat" cmpd="sng" algn="ctr">
-                      <a:solidFill>
-                        <a:schemeClr val="accent1"/>
-                      </a:solidFill>
-                      <a:prstDash val="solid"/>
-                      <a:round/>
-                      <a:headEnd type="none" w="med" len="med"/>
-                      <a:tailEnd type="none" w="med" len="med"/>
-                    </a:lnB>
-                  </a:tcPr>
-                </a:tc>
-                <a:tc rowSpan="4" hMerge="1">
-                  <a:txBody>
-                    <a:bodyPr/>
-                    <a:lstStyle/>
-                    <a:p>
-                      <a:endParaRPr lang="en-US"/>
-                    </a:p>
-                  </a:txBody>
-                  <a:tcPr/>
-                </a:tc>
-                <a:tc rowSpan="4" hMerge="1">
-                  <a:txBody>
-                    <a:bodyPr/>
-                    <a:lstStyle/>
-                    <a:p>
-                      <a:endParaRPr lang="en-US" sz="1200" dirty="0"/>
+                <a:tc rowSpan="4">
+                  <a:txBody>
+                    <a:bodyPr/>
+                    <a:lstStyle/>
+                    <a:p>
+                      <a:pPr algn="ctr"/>
+                      <a:r>
+                        <a:rPr lang="en-US" sz="1200" dirty="0">
+                          <a:latin typeface="Arial" panose="020B0604020202020204" pitchFamily="34" charset="0"/>
+                          <a:cs typeface="Arial" panose="020B0604020202020204" pitchFamily="34" charset="0"/>
+                        </a:rPr>
+                        <a:t>[9:20] </a:t>
+                      </a:r>
+                    </a:p>
+                    <a:p>
+                      <a:pPr algn="ctr"/>
+                      <a:r>
+                        <a:rPr lang="en-US" sz="1200" dirty="0">
+                          <a:latin typeface="Arial" panose="020B0604020202020204" pitchFamily="34" charset="0"/>
+                          <a:cs typeface="Arial" panose="020B0604020202020204" pitchFamily="34" charset="0"/>
+                        </a:rPr>
+                        <a:t>BrainHack Toronto Committee Meeting </a:t>
+                      </a:r>
+                      <a:br>
+                        <a:rPr lang="en-US" sz="1200" dirty="0">
+                          <a:latin typeface="Arial" panose="020B0604020202020204" pitchFamily="34" charset="0"/>
+                          <a:cs typeface="Arial" panose="020B0604020202020204" pitchFamily="34" charset="0"/>
+                        </a:rPr>
+                      </a:br>
+                      <a:r>
+                        <a:rPr lang="en-US" sz="1200" dirty="0">
+                          <a:latin typeface="Arial" panose="020B0604020202020204" pitchFamily="34" charset="0"/>
+                          <a:cs typeface="Arial" panose="020B0604020202020204" pitchFamily="34" charset="0"/>
+                        </a:rPr>
+                        <a:t>(all are invited)</a:t>
+                      </a:r>
+                      <a:endParaRPr lang="en-US" dirty="0"/>
                     </a:p>
                   </a:txBody>
                   <a:tcPr marL="93811" marR="93811" marT="46906" marB="46906" anchor="ctr">
@@ -4175,13 +4121,21 @@
                     </a:lnR>
                     <a:lnB w="12700" cap="flat" cmpd="sng" algn="ctr">
                       <a:solidFill>
-                        <a:schemeClr val="accent1"/>
+                        <a:schemeClr val="bg1">
+                          <a:lumMod val="65000"/>
+                        </a:schemeClr>
                       </a:solidFill>
                       <a:prstDash val="solid"/>
                       <a:round/>
                       <a:headEnd type="none" w="med" len="med"/>
                       <a:tailEnd type="none" w="med" len="med"/>
                     </a:lnB>
+                    <a:solidFill>
+                      <a:schemeClr val="accent1">
+                        <a:lumMod val="20000"/>
+                        <a:lumOff val="80000"/>
+                      </a:schemeClr>
+                    </a:solidFill>
                   </a:tcPr>
                 </a:tc>
                 <a:extLst>
@@ -4391,7 +4345,7 @@
                   </a:txBody>
                   <a:tcPr/>
                 </a:tc>
-                <a:tc gridSpan="4" vMerge="1">
+                <a:tc vMerge="1">
                   <a:txBody>
                     <a:bodyPr/>
                     <a:lstStyle/>
@@ -4444,37 +4398,7 @@
                     </a:lnB>
                   </a:tcPr>
                 </a:tc>
-                <a:tc hMerge="1" vMerge="1">
-                  <a:txBody>
-                    <a:bodyPr/>
-                    <a:lstStyle/>
-                    <a:p>
-                      <a:endParaRPr lang="en-US"/>
-                    </a:p>
-                  </a:txBody>
-                  <a:tcPr>
-                    <a:lnT w="12700" cap="flat" cmpd="sng" algn="ctr">
-                      <a:solidFill>
-                        <a:schemeClr val="accent1"/>
-                      </a:solidFill>
-                      <a:prstDash val="solid"/>
-                      <a:round/>
-                      <a:headEnd type="none" w="med" len="med"/>
-                      <a:tailEnd type="none" w="med" len="med"/>
-                    </a:lnT>
-                  </a:tcPr>
-                </a:tc>
-                <a:tc hMerge="1" vMerge="1">
-                  <a:txBody>
-                    <a:bodyPr/>
-                    <a:lstStyle/>
-                    <a:p>
-                      <a:endParaRPr lang="en-US"/>
-                    </a:p>
-                  </a:txBody>
-                  <a:tcPr/>
-                </a:tc>
-                <a:tc hMerge="1" vMerge="1">
+                <a:tc vMerge="1">
                   <a:txBody>
                     <a:bodyPr/>
                     <a:lstStyle/>
@@ -4617,7 +4541,7 @@
                   </a:txBody>
                   <a:tcPr/>
                 </a:tc>
-                <a:tc gridSpan="4" vMerge="1">
+                <a:tc vMerge="1">
                   <a:txBody>
                     <a:bodyPr/>
                     <a:lstStyle/>
@@ -4639,7 +4563,7 @@
                     </a:lnT>
                   </a:tcPr>
                 </a:tc>
-                <a:tc hMerge="1" vMerge="1">
+                <a:tc vMerge="1">
                   <a:txBody>
                     <a:bodyPr/>
                     <a:lstStyle/>
@@ -4648,36 +4572,6 @@
                     </a:p>
                   </a:txBody>
                   <a:tcPr/>
-                </a:tc>
-                <a:tc hMerge="1" vMerge="1">
-                  <a:txBody>
-                    <a:bodyPr/>
-                    <a:lstStyle/>
-                    <a:p>
-                      <a:endParaRPr lang="en-US"/>
-                    </a:p>
-                  </a:txBody>
-                  <a:tcPr/>
-                </a:tc>
-                <a:tc hMerge="1" vMerge="1">
-                  <a:txBody>
-                    <a:bodyPr/>
-                    <a:lstStyle/>
-                    <a:p>
-                      <a:endParaRPr lang="en-US"/>
-                    </a:p>
-                  </a:txBody>
-                  <a:tcPr>
-                    <a:lnT w="12700" cap="flat" cmpd="sng" algn="ctr">
-                      <a:solidFill>
-                        <a:schemeClr val="accent1"/>
-                      </a:solidFill>
-                      <a:prstDash val="solid"/>
-                      <a:round/>
-                      <a:headEnd type="none" w="med" len="med"/>
-                      <a:tailEnd type="none" w="med" len="med"/>
-                    </a:lnT>
-                  </a:tcPr>
                 </a:tc>
                 <a:extLst>
                   <a:ext uri="{0D108BD9-81ED-4DB2-BD59-A6C34878D82A}">
@@ -4888,7 +4782,7 @@
                   </a:txBody>
                   <a:tcPr/>
                 </a:tc>
-                <a:tc gridSpan="4" vMerge="1">
+                <a:tc vMerge="1">
                   <a:txBody>
                     <a:bodyPr/>
                     <a:lstStyle/>
@@ -4943,64 +4837,7 @@
                     </a:lnB>
                   </a:tcPr>
                 </a:tc>
-                <a:tc hMerge="1" vMerge="1">
-                  <a:txBody>
-                    <a:bodyPr/>
-                    <a:lstStyle/>
-                    <a:p>
-                      <a:pPr algn="ctr"/>
-                      <a:endParaRPr lang="en-US" sz="1200" dirty="0">
-                        <a:latin typeface="Arial" panose="020B0604020202020204" pitchFamily="34" charset="0"/>
-                        <a:cs typeface="Arial" panose="020B0604020202020204" pitchFamily="34" charset="0"/>
-                      </a:endParaRPr>
-                    </a:p>
-                  </a:txBody>
-                  <a:tcPr marL="93811" marR="93811" marT="46906" marB="46906" anchor="ctr">
-                    <a:lnL w="12700" cap="flat" cmpd="sng" algn="ctr">
-                      <a:solidFill>
-                        <a:schemeClr val="accent1"/>
-                      </a:solidFill>
-                      <a:prstDash val="solid"/>
-                      <a:round/>
-                      <a:headEnd type="none" w="med" len="med"/>
-                      <a:tailEnd type="none" w="med" len="med"/>
-                    </a:lnL>
-                    <a:lnR w="12700" cap="flat" cmpd="sng" algn="ctr">
-                      <a:solidFill>
-                        <a:schemeClr val="accent1"/>
-                      </a:solidFill>
-                      <a:prstDash val="solid"/>
-                      <a:round/>
-                      <a:headEnd type="none" w="med" len="med"/>
-                      <a:tailEnd type="none" w="med" len="med"/>
-                    </a:lnR>
-                    <a:lnT w="12700" cap="flat" cmpd="sng" algn="ctr">
-                      <a:solidFill>
-                        <a:schemeClr val="accent1"/>
-                      </a:solidFill>
-                      <a:prstDash val="solid"/>
-                      <a:round/>
-                      <a:headEnd type="none" w="med" len="med"/>
-                      <a:tailEnd type="none" w="med" len="med"/>
-                    </a:lnT>
-                    <a:lnB w="12700" cap="flat" cmpd="sng" algn="ctr">
-                      <a:solidFill>
-                        <a:schemeClr val="accent1"/>
-                      </a:solidFill>
-                      <a:prstDash val="solid"/>
-                      <a:round/>
-                      <a:headEnd type="none" w="med" len="med"/>
-                      <a:tailEnd type="none" w="med" len="med"/>
-                    </a:lnB>
-                    <a:solidFill>
-                      <a:schemeClr val="accent1">
-                        <a:lumMod val="20000"/>
-                        <a:lumOff val="80000"/>
-                      </a:schemeClr>
-                    </a:solidFill>
-                  </a:tcPr>
-                </a:tc>
-                <a:tc hMerge="1" vMerge="1">
+                <a:tc vMerge="1">
                   <a:txBody>
                     <a:bodyPr/>
                     <a:lstStyle/>
@@ -5009,59 +4846,6 @@
                     </a:p>
                   </a:txBody>
                   <a:tcPr/>
-                </a:tc>
-                <a:tc hMerge="1" vMerge="1">
-                  <a:txBody>
-                    <a:bodyPr/>
-                    <a:lstStyle/>
-                    <a:p>
-                      <a:pPr algn="ctr"/>
-                      <a:endParaRPr lang="en-US" sz="1200" dirty="0">
-                        <a:latin typeface="Arial" panose="020B0604020202020204" pitchFamily="34" charset="0"/>
-                        <a:cs typeface="Arial" panose="020B0604020202020204" pitchFamily="34" charset="0"/>
-                      </a:endParaRPr>
-                    </a:p>
-                  </a:txBody>
-                  <a:tcPr anchor="ctr">
-                    <a:lnL w="12700" cap="flat" cmpd="sng" algn="ctr">
-                      <a:solidFill>
-                        <a:schemeClr val="accent1"/>
-                      </a:solidFill>
-                      <a:prstDash val="solid"/>
-                      <a:round/>
-                      <a:headEnd type="none" w="med" len="med"/>
-                      <a:tailEnd type="none" w="med" len="med"/>
-                    </a:lnL>
-                    <a:lnR w="12700" cap="flat" cmpd="sng" algn="ctr">
-                      <a:solidFill>
-                        <a:schemeClr val="accent1"/>
-                      </a:solidFill>
-                      <a:prstDash val="solid"/>
-                      <a:round/>
-                      <a:headEnd type="none" w="med" len="med"/>
-                      <a:tailEnd type="none" w="med" len="med"/>
-                    </a:lnR>
-                    <a:lnT w="12700" cap="flat" cmpd="sng" algn="ctr">
-                      <a:solidFill>
-                        <a:schemeClr val="accent1"/>
-                      </a:solidFill>
-                      <a:prstDash val="solid"/>
-                      <a:round/>
-                      <a:headEnd type="none" w="med" len="med"/>
-                      <a:tailEnd type="none" w="med" len="med"/>
-                    </a:lnT>
-                    <a:lnB w="12700" cap="flat" cmpd="sng" algn="ctr">
-                      <a:solidFill>
-                        <a:schemeClr val="bg1">
-                          <a:lumMod val="65000"/>
-                        </a:schemeClr>
-                      </a:solidFill>
-                      <a:prstDash val="solid"/>
-                      <a:round/>
-                      <a:headEnd type="none" w="med" len="med"/>
-                      <a:tailEnd type="none" w="med" len="med"/>
-                    </a:lnB>
-                  </a:tcPr>
                 </a:tc>
                 <a:extLst>
                   <a:ext uri="{0D108BD9-81ED-4DB2-BD59-A6C34878D82A}">
@@ -5166,7 +4950,7 @@
                   </a:txBody>
                   <a:tcPr/>
                 </a:tc>
-                <a:tc rowSpan="2" gridSpan="4">
+                <a:tc rowSpan="2" gridSpan="2">
                   <a:txBody>
                     <a:bodyPr/>
                     <a:lstStyle/>
@@ -5203,7 +4987,7 @@
                     <a:lnT w="12700" cap="flat" cmpd="sng" algn="ctr">
                       <a:solidFill>
                         <a:schemeClr val="bg1">
-                          <a:lumMod val="75000"/>
+                          <a:lumMod val="65000"/>
                         </a:schemeClr>
                       </a:solidFill>
                       <a:prstDash val="solid"/>
@@ -5223,109 +5007,30 @@
                     <a:bodyPr/>
                     <a:lstStyle/>
                     <a:p>
-                      <a:endParaRPr lang="en-US" dirty="0"/>
-                    </a:p>
-                  </a:txBody>
-                  <a:tcPr marL="93811" marR="93811" marT="46906" marB="46906" anchor="ctr">
-                    <a:lnL w="12700" cap="flat" cmpd="sng" algn="ctr">
-                      <a:solidFill>
-                        <a:schemeClr val="accent1"/>
-                      </a:solidFill>
-                      <a:prstDash val="solid"/>
-                      <a:round/>
-                      <a:headEnd type="none" w="med" len="med"/>
-                      <a:tailEnd type="none" w="med" len="med"/>
-                    </a:lnL>
-                    <a:lnR w="12700" cap="flat" cmpd="sng" algn="ctr">
-                      <a:solidFill>
-                        <a:schemeClr val="accent1"/>
-                      </a:solidFill>
-                      <a:prstDash val="solid"/>
-                      <a:round/>
-                      <a:headEnd type="none" w="med" len="med"/>
-                      <a:tailEnd type="none" w="med" len="med"/>
-                    </a:lnR>
-                    <a:lnT w="12700" cap="flat" cmpd="sng" algn="ctr">
-                      <a:solidFill>
-                        <a:schemeClr val="accent1"/>
-                      </a:solidFill>
-                      <a:prstDash val="solid"/>
-                      <a:round/>
-                      <a:headEnd type="none" w="med" len="med"/>
-                      <a:tailEnd type="none" w="med" len="med"/>
-                    </a:lnT>
-                    <a:lnB w="12700" cap="flat" cmpd="sng" algn="ctr">
-                      <a:solidFill>
-                        <a:schemeClr val="accent1"/>
-                      </a:solidFill>
-                      <a:prstDash val="solid"/>
-                      <a:round/>
-                      <a:headEnd type="none" w="med" len="med"/>
-                      <a:tailEnd type="none" w="med" len="med"/>
-                    </a:lnB>
-                    <a:solidFill>
-                      <a:schemeClr val="accent1">
-                        <a:lumMod val="20000"/>
-                        <a:lumOff val="80000"/>
-                      </a:schemeClr>
-                    </a:solidFill>
-                  </a:tcPr>
-                </a:tc>
-                <a:tc rowSpan="2" hMerge="1">
-                  <a:txBody>
-                    <a:bodyPr/>
-                    <a:lstStyle/>
-                    <a:p>
                       <a:endParaRPr lang="en-US"/>
                     </a:p>
                   </a:txBody>
-                  <a:tcPr/>
-                </a:tc>
-                <a:tc rowSpan="2" hMerge="1">
-                  <a:txBody>
-                    <a:bodyPr/>
-                    <a:lstStyle/>
-                    <a:p>
-                      <a:endParaRPr lang="en-US" dirty="0"/>
-                    </a:p>
-                  </a:txBody>
-                  <a:tcPr marL="93811" marR="93811" marT="46906" marB="46906" anchor="ctr">
-                    <a:lnL w="12700" cap="flat" cmpd="sng" algn="ctr">
-                      <a:solidFill>
-                        <a:schemeClr val="accent1"/>
-                      </a:solidFill>
-                      <a:prstDash val="solid"/>
-                      <a:round/>
-                      <a:headEnd type="none" w="med" len="med"/>
-                      <a:tailEnd type="none" w="med" len="med"/>
-                    </a:lnL>
-                    <a:lnR w="12700" cap="flat" cmpd="sng" algn="ctr">
-                      <a:solidFill>
-                        <a:schemeClr val="accent1"/>
-                      </a:solidFill>
-                      <a:prstDash val="solid"/>
-                      <a:round/>
-                      <a:headEnd type="none" w="med" len="med"/>
-                      <a:tailEnd type="none" w="med" len="med"/>
-                    </a:lnR>
-                    <a:lnT w="12700" cap="flat" cmpd="sng" algn="ctr">
-                      <a:solidFill>
-                        <a:schemeClr val="accent1"/>
-                      </a:solidFill>
-                      <a:prstDash val="solid"/>
-                      <a:round/>
-                      <a:headEnd type="none" w="med" len="med"/>
-                      <a:tailEnd type="none" w="med" len="med"/>
-                    </a:lnT>
-                    <a:lnB w="12700" cap="flat" cmpd="sng" algn="ctr">
-                      <a:solidFill>
-                        <a:schemeClr val="accent1"/>
-                      </a:solidFill>
-                      <a:prstDash val="solid"/>
-                      <a:round/>
-                      <a:headEnd type="none" w="med" len="med"/>
-                      <a:tailEnd type="none" w="med" len="med"/>
-                    </a:lnB>
+                  <a:tcPr>
+                    <a:lnL w="12700" cap="flat" cmpd="sng" algn="ctr">
+                      <a:solidFill>
+                        <a:schemeClr val="accent1"/>
+                      </a:solidFill>
+                      <a:prstDash val="solid"/>
+                      <a:round/>
+                      <a:headEnd type="none" w="med" len="med"/>
+                      <a:tailEnd type="none" w="med" len="med"/>
+                    </a:lnL>
+                    <a:lnT w="12700" cap="flat" cmpd="sng" algn="ctr">
+                      <a:solidFill>
+                        <a:schemeClr val="bg1">
+                          <a:lumMod val="65000"/>
+                        </a:schemeClr>
+                      </a:solidFill>
+                      <a:prstDash val="solid"/>
+                      <a:round/>
+                      <a:headEnd type="none" w="med" len="med"/>
+                      <a:tailEnd type="none" w="med" len="med"/>
+                    </a:lnT>
                   </a:tcPr>
                 </a:tc>
                 <a:extLst>
@@ -5591,7 +5296,7 @@
                     </a:solidFill>
                   </a:tcPr>
                 </a:tc>
-                <a:tc gridSpan="4" vMerge="1">
+                <a:tc gridSpan="2" vMerge="1">
                   <a:txBody>
                     <a:bodyPr/>
                     <a:lstStyle/>
@@ -5628,26 +5333,6 @@
                       </a:schemeClr>
                     </a:solidFill>
                   </a:tcPr>
-                </a:tc>
-                <a:tc hMerge="1" vMerge="1">
-                  <a:txBody>
-                    <a:bodyPr/>
-                    <a:lstStyle/>
-                    <a:p>
-                      <a:endParaRPr lang="en-US"/>
-                    </a:p>
-                  </a:txBody>
-                  <a:tcPr/>
-                </a:tc>
-                <a:tc hMerge="1" vMerge="1">
-                  <a:txBody>
-                    <a:bodyPr/>
-                    <a:lstStyle/>
-                    <a:p>
-                      <a:endParaRPr lang="en-US"/>
-                    </a:p>
-                  </a:txBody>
-                  <a:tcPr/>
                 </a:tc>
                 <a:tc hMerge="1" vMerge="1">
                   <a:txBody>
@@ -5778,6 +5463,7 @@
                     <a:bodyPr/>
                     <a:lstStyle/>
                     <a:p>
+                      <a:pPr algn="ctr"/>
                       <a:r>
                         <a:rPr lang="en-US" sz="1200" dirty="0">
                           <a:latin typeface="Arial" panose="020B0604020202020204" pitchFamily="34" charset="0"/>
@@ -5807,17 +5493,6 @@
                       <a:headEnd type="none" w="med" len="med"/>
                       <a:tailEnd type="none" w="med" len="med"/>
                     </a:lnR>
-                    <a:lnT w="12700" cap="flat" cmpd="sng" algn="ctr">
-                      <a:solidFill>
-                        <a:schemeClr val="bg1">
-                          <a:lumMod val="75000"/>
-                        </a:schemeClr>
-                      </a:solidFill>
-                      <a:prstDash val="solid"/>
-                      <a:round/>
-                      <a:headEnd type="none" w="med" len="med"/>
-                      <a:tailEnd type="none" w="med" len="med"/>
-                    </a:lnT>
                     <a:lnB w="12700" cap="flat" cmpd="sng" algn="ctr">
                       <a:solidFill>
                         <a:schemeClr val="accent1"/>
@@ -5829,15 +5504,12 @@
                     </a:lnB>
                   </a:tcPr>
                 </a:tc>
-                <a:tc gridSpan="2">
-                  <a:txBody>
-                    <a:bodyPr/>
-                    <a:lstStyle/>
-                    <a:p>
-                      <a:endParaRPr lang="en-US" sz="1200" dirty="0">
-                        <a:latin typeface="Arial" panose="020B0604020202020204" pitchFamily="34" charset="0"/>
-                        <a:cs typeface="Arial" panose="020B0604020202020204" pitchFamily="34" charset="0"/>
-                      </a:endParaRPr>
+                <a:tc>
+                  <a:txBody>
+                    <a:bodyPr/>
+                    <a:lstStyle/>
+                    <a:p>
+                      <a:endParaRPr lang="en-US"/>
                     </a:p>
                   </a:txBody>
                   <a:tcPr marL="93811" marR="93811" marT="46906" marB="46906" anchor="ctr">
@@ -5859,17 +5531,6 @@
                       <a:headEnd type="none" w="med" len="med"/>
                       <a:tailEnd type="none" w="med" len="med"/>
                     </a:lnR>
-                    <a:lnT w="12700" cap="flat" cmpd="sng" algn="ctr">
-                      <a:solidFill>
-                        <a:schemeClr val="bg1">
-                          <a:lumMod val="75000"/>
-                        </a:schemeClr>
-                      </a:solidFill>
-                      <a:prstDash val="solid"/>
-                      <a:round/>
-                      <a:headEnd type="none" w="med" len="med"/>
-                      <a:tailEnd type="none" w="med" len="med"/>
-                    </a:lnT>
                     <a:lnB w="12700" cap="flat" cmpd="sng" algn="ctr">
                       <a:solidFill>
                         <a:schemeClr val="accent1"/>
@@ -5879,90 +5540,6 @@
                       <a:headEnd type="none" w="med" len="med"/>
                       <a:tailEnd type="none" w="med" len="med"/>
                     </a:lnB>
-                  </a:tcPr>
-                </a:tc>
-                <a:tc hMerge="1">
-                  <a:txBody>
-                    <a:bodyPr/>
-                    <a:lstStyle/>
-                    <a:p>
-                      <a:endParaRPr lang="en-US"/>
-                    </a:p>
-                  </a:txBody>
-                  <a:tcPr/>
-                </a:tc>
-                <a:tc rowSpan="3">
-                  <a:txBody>
-                    <a:bodyPr/>
-                    <a:lstStyle/>
-                    <a:p>
-                      <a:pPr algn="ctr"/>
-                      <a:r>
-                        <a:rPr lang="en-US" sz="1200" dirty="0">
-                          <a:latin typeface="Arial" panose="020B0604020202020204" pitchFamily="34" charset="0"/>
-                          <a:cs typeface="Arial" panose="020B0604020202020204" pitchFamily="34" charset="0"/>
-                        </a:rPr>
-                        <a:t>[10: 40] BrainHack Toronto Committee Meeting </a:t>
-                      </a:r>
-                      <a:br>
-                        <a:rPr lang="en-US" sz="1200" dirty="0">
-                          <a:latin typeface="Arial" panose="020B0604020202020204" pitchFamily="34" charset="0"/>
-                          <a:cs typeface="Arial" panose="020B0604020202020204" pitchFamily="34" charset="0"/>
-                        </a:rPr>
-                      </a:br>
-                      <a:r>
-                        <a:rPr lang="en-US" sz="1200" dirty="0">
-                          <a:latin typeface="Arial" panose="020B0604020202020204" pitchFamily="34" charset="0"/>
-                          <a:cs typeface="Arial" panose="020B0604020202020204" pitchFamily="34" charset="0"/>
-                        </a:rPr>
-                        <a:t>(all are invited)</a:t>
-                      </a:r>
-                      <a:endParaRPr lang="en-US" dirty="0"/>
-                    </a:p>
-                  </a:txBody>
-                  <a:tcPr marL="93811" marR="93811" marT="46906" marB="46906" anchor="ctr">
-                    <a:lnL w="12700" cap="flat" cmpd="sng" algn="ctr">
-                      <a:solidFill>
-                        <a:schemeClr val="accent1"/>
-                      </a:solidFill>
-                      <a:prstDash val="solid"/>
-                      <a:round/>
-                      <a:headEnd type="none" w="med" len="med"/>
-                      <a:tailEnd type="none" w="med" len="med"/>
-                    </a:lnL>
-                    <a:lnR w="12700" cap="flat" cmpd="sng" algn="ctr">
-                      <a:solidFill>
-                        <a:schemeClr val="accent1"/>
-                      </a:solidFill>
-                      <a:prstDash val="solid"/>
-                      <a:round/>
-                      <a:headEnd type="none" w="med" len="med"/>
-                      <a:tailEnd type="none" w="med" len="med"/>
-                    </a:lnR>
-                    <a:lnT w="12700" cap="flat" cmpd="sng" algn="ctr">
-                      <a:solidFill>
-                        <a:schemeClr val="accent1"/>
-                      </a:solidFill>
-                      <a:prstDash val="solid"/>
-                      <a:round/>
-                      <a:headEnd type="none" w="med" len="med"/>
-                      <a:tailEnd type="none" w="med" len="med"/>
-                    </a:lnT>
-                    <a:lnB w="12700" cap="flat" cmpd="sng" algn="ctr">
-                      <a:solidFill>
-                        <a:schemeClr val="accent1"/>
-                      </a:solidFill>
-                      <a:prstDash val="solid"/>
-                      <a:round/>
-                      <a:headEnd type="none" w="med" len="med"/>
-                      <a:tailEnd type="none" w="med" len="med"/>
-                    </a:lnB>
-                    <a:solidFill>
-                      <a:schemeClr val="accent1">
-                        <a:lumMod val="20000"/>
-                        <a:lumOff val="80000"/>
-                      </a:schemeClr>
-                    </a:solidFill>
                   </a:tcPr>
                 </a:tc>
                 <a:extLst>
@@ -5971,7 +5548,7 @@
                   </a:ext>
                 </a:extLst>
               </a:tr>
-              <a:tr h="249316">
+              <a:tr h="346626">
                 <a:tc>
                   <a:txBody>
                     <a:bodyPr/>
@@ -6088,7 +5665,7 @@
                   </a:txBody>
                   <a:tcPr/>
                 </a:tc>
-                <a:tc rowSpan="2" gridSpan="2">
+                <a:tc rowSpan="2">
                   <a:txBody>
                     <a:bodyPr/>
                     <a:lstStyle/>
@@ -6118,10 +5695,7 @@
                         <a:rPr lang="en-US" sz="1200" b="1" i="1" dirty="0"/>
                         <a:t>Introduction to deep learning and AI</a:t>
                       </a:r>
-                      <a:endParaRPr lang="en-US" sz="1200" dirty="0">
-                        <a:latin typeface="Arial" panose="020B0604020202020204" pitchFamily="34" charset="0"/>
-                        <a:cs typeface="Arial" panose="020B0604020202020204" pitchFamily="34" charset="0"/>
-                      </a:endParaRPr>
+                      <a:endParaRPr lang="en-US" dirty="0"/>
                     </a:p>
                   </a:txBody>
                   <a:tcPr marL="93811" marR="93811" marT="46906" marB="46906" anchor="ctr">
@@ -6168,26 +5742,6 @@
                       </a:schemeClr>
                     </a:solidFill>
                   </a:tcPr>
-                </a:tc>
-                <a:tc rowSpan="2" hMerge="1">
-                  <a:txBody>
-                    <a:bodyPr/>
-                    <a:lstStyle/>
-                    <a:p>
-                      <a:endParaRPr lang="en-US"/>
-                    </a:p>
-                  </a:txBody>
-                  <a:tcPr/>
-                </a:tc>
-                <a:tc vMerge="1">
-                  <a:txBody>
-                    <a:bodyPr/>
-                    <a:lstStyle/>
-                    <a:p>
-                      <a:endParaRPr lang="en-US"/>
-                    </a:p>
-                  </a:txBody>
-                  <a:tcPr/>
                 </a:tc>
                 <a:extLst>
                   <a:ext uri="{0D108BD9-81ED-4DB2-BD59-A6C34878D82A}">
@@ -6345,7 +5899,26 @@
                       <a:endParaRPr lang="en-US"/>
                     </a:p>
                   </a:txBody>
-                  <a:tcPr/>
+                  <a:tcPr>
+                    <a:lnL w="12700" cap="flat" cmpd="sng" algn="ctr">
+                      <a:solidFill>
+                        <a:schemeClr val="accent1"/>
+                      </a:solidFill>
+                      <a:prstDash val="solid"/>
+                      <a:round/>
+                      <a:headEnd type="none" w="med" len="med"/>
+                      <a:tailEnd type="none" w="med" len="med"/>
+                    </a:lnL>
+                    <a:lnT w="12700" cap="flat" cmpd="sng" algn="ctr">
+                      <a:solidFill>
+                        <a:schemeClr val="accent1"/>
+                      </a:solidFill>
+                      <a:prstDash val="solid"/>
+                      <a:round/>
+                      <a:headEnd type="none" w="med" len="med"/>
+                      <a:tailEnd type="none" w="med" len="med"/>
+                    </a:lnT>
+                  </a:tcPr>
                 </a:tc>
                 <a:tc>
                   <a:txBody>
@@ -6406,27 +5979,26 @@
                       <a:endParaRPr lang="en-US"/>
                     </a:p>
                   </a:txBody>
-                  <a:tcPr/>
-                </a:tc>
-                <a:tc gridSpan="2" vMerge="1">
-                  <a:txBody>
-                    <a:bodyPr/>
-                    <a:lstStyle/>
-                    <a:p>
-                      <a:endParaRPr lang="en-US"/>
-                    </a:p>
-                  </a:txBody>
-                  <a:tcPr/>
-                </a:tc>
-                <a:tc hMerge="1" vMerge="1">
-                  <a:txBody>
-                    <a:bodyPr/>
-                    <a:lstStyle/>
-                    <a:p>
-                      <a:endParaRPr lang="en-US"/>
-                    </a:p>
-                  </a:txBody>
-                  <a:tcPr/>
+                  <a:tcPr>
+                    <a:lnL w="12700" cap="flat" cmpd="sng" algn="ctr">
+                      <a:solidFill>
+                        <a:schemeClr val="accent1"/>
+                      </a:solidFill>
+                      <a:prstDash val="solid"/>
+                      <a:round/>
+                      <a:headEnd type="none" w="med" len="med"/>
+                      <a:tailEnd type="none" w="med" len="med"/>
+                    </a:lnL>
+                    <a:lnT w="12700" cap="flat" cmpd="sng" algn="ctr">
+                      <a:solidFill>
+                        <a:schemeClr val="accent1"/>
+                      </a:solidFill>
+                      <a:prstDash val="solid"/>
+                      <a:round/>
+                      <a:headEnd type="none" w="med" len="med"/>
+                      <a:tailEnd type="none" w="med" len="med"/>
+                    </a:lnT>
+                  </a:tcPr>
                 </a:tc>
                 <a:tc vMerge="1">
                   <a:txBody>
@@ -6645,7 +6217,7 @@
                     </a:solidFill>
                   </a:tcPr>
                 </a:tc>
-                <a:tc rowSpan="2" gridSpan="4">
+                <a:tc rowSpan="2" gridSpan="2">
                   <a:txBody>
                     <a:bodyPr/>
                     <a:lstStyle/>
@@ -6710,119 +6282,19 @@
                     <a:bodyPr/>
                     <a:lstStyle/>
                     <a:p>
-                      <a:endParaRPr lang="en-US" sz="1200" dirty="0">
-                        <a:latin typeface="Arial" panose="020B0604020202020204" pitchFamily="34" charset="0"/>
-                        <a:cs typeface="Arial" panose="020B0604020202020204" pitchFamily="34" charset="0"/>
-                      </a:endParaRPr>
-                    </a:p>
-                  </a:txBody>
-                  <a:tcPr marL="93811" marR="93811" marT="46906" marB="46906" anchor="ctr">
-                    <a:lnL w="12700" cap="flat" cmpd="sng" algn="ctr">
-                      <a:solidFill>
-                        <a:schemeClr val="accent1"/>
-                      </a:solidFill>
-                      <a:prstDash val="solid"/>
-                      <a:round/>
-                      <a:headEnd type="none" w="med" len="med"/>
-                      <a:tailEnd type="none" w="med" len="med"/>
-                    </a:lnL>
-                    <a:lnR w="12700" cap="flat" cmpd="sng" algn="ctr">
-                      <a:solidFill>
-                        <a:schemeClr val="accent1"/>
-                      </a:solidFill>
-                      <a:prstDash val="solid"/>
-                      <a:round/>
-                      <a:headEnd type="none" w="med" len="med"/>
-                      <a:tailEnd type="none" w="med" len="med"/>
-                    </a:lnR>
-                    <a:lnT w="12700" cap="flat" cmpd="sng" algn="ctr">
-                      <a:solidFill>
-                        <a:schemeClr val="accent1"/>
-                      </a:solidFill>
-                      <a:prstDash val="solid"/>
-                      <a:round/>
-                      <a:headEnd type="none" w="med" len="med"/>
-                      <a:tailEnd type="none" w="med" len="med"/>
-                    </a:lnT>
-                    <a:lnB w="12700" cap="flat" cmpd="sng" algn="ctr">
-                      <a:solidFill>
-                        <a:schemeClr val="accent1"/>
-                      </a:solidFill>
-                      <a:prstDash val="solid"/>
-                      <a:round/>
-                      <a:headEnd type="none" w="med" len="med"/>
-                      <a:tailEnd type="none" w="med" len="med"/>
-                    </a:lnB>
-                    <a:solidFill>
-                      <a:schemeClr val="accent1">
-                        <a:lumMod val="20000"/>
-                        <a:lumOff val="80000"/>
-                      </a:schemeClr>
-                    </a:solidFill>
-                  </a:tcPr>
-                </a:tc>
-                <a:tc rowSpan="2" hMerge="1">
-                  <a:txBody>
-                    <a:bodyPr/>
-                    <a:lstStyle/>
-                    <a:p>
                       <a:endParaRPr lang="en-US"/>
                     </a:p>
                   </a:txBody>
-                  <a:tcPr/>
-                </a:tc>
-                <a:tc rowSpan="2" hMerge="1">
-                  <a:txBody>
-                    <a:bodyPr/>
-                    <a:lstStyle/>
-                    <a:p>
-                      <a:pPr algn="ctr"/>
-                      <a:endParaRPr lang="en-US" dirty="0"/>
-                    </a:p>
-                  </a:txBody>
-                  <a:tcPr marL="93811" marR="93811" marT="46906" marB="46906" anchor="ctr">
-                    <a:lnL w="12700" cap="flat" cmpd="sng" algn="ctr">
-                      <a:solidFill>
-                        <a:schemeClr val="accent1"/>
-                      </a:solidFill>
-                      <a:prstDash val="solid"/>
-                      <a:round/>
-                      <a:headEnd type="none" w="med" len="med"/>
-                      <a:tailEnd type="none" w="med" len="med"/>
-                    </a:lnL>
-                    <a:lnR w="12700" cap="flat" cmpd="sng" algn="ctr">
-                      <a:solidFill>
-                        <a:schemeClr val="accent1"/>
-                      </a:solidFill>
-                      <a:prstDash val="solid"/>
-                      <a:round/>
-                      <a:headEnd type="none" w="med" len="med"/>
-                      <a:tailEnd type="none" w="med" len="med"/>
-                    </a:lnR>
-                    <a:lnT w="12700" cap="flat" cmpd="sng" algn="ctr">
-                      <a:solidFill>
-                        <a:schemeClr val="accent1"/>
-                      </a:solidFill>
-                      <a:prstDash val="solid"/>
-                      <a:round/>
-                      <a:headEnd type="none" w="med" len="med"/>
-                      <a:tailEnd type="none" w="med" len="med"/>
-                    </a:lnT>
-                    <a:lnB w="12700" cap="flat" cmpd="sng" algn="ctr">
-                      <a:solidFill>
-                        <a:schemeClr val="accent1"/>
-                      </a:solidFill>
-                      <a:prstDash val="solid"/>
-                      <a:round/>
-                      <a:headEnd type="none" w="med" len="med"/>
-                      <a:tailEnd type="none" w="med" len="med"/>
-                    </a:lnB>
-                    <a:solidFill>
-                      <a:schemeClr val="accent1">
-                        <a:lumMod val="20000"/>
-                        <a:lumOff val="80000"/>
-                      </a:schemeClr>
-                    </a:solidFill>
+                  <a:tcPr>
+                    <a:lnL w="12700" cap="flat" cmpd="sng" algn="ctr">
+                      <a:solidFill>
+                        <a:schemeClr val="accent1"/>
+                      </a:solidFill>
+                      <a:prstDash val="solid"/>
+                      <a:round/>
+                      <a:headEnd type="none" w="med" len="med"/>
+                      <a:tailEnd type="none" w="med" len="med"/>
+                    </a:lnL>
                   </a:tcPr>
                 </a:tc>
                 <a:extLst>
@@ -7020,7 +6492,7 @@
                   </a:txBody>
                   <a:tcPr/>
                 </a:tc>
-                <a:tc gridSpan="4" vMerge="1">
+                <a:tc gridSpan="2" vMerge="1">
                   <a:txBody>
                     <a:bodyPr/>
                     <a:lstStyle/>
@@ -7070,26 +6542,6 @@
                       <a:tailEnd type="none" w="med" len="med"/>
                     </a:lnB>
                   </a:tcPr>
-                </a:tc>
-                <a:tc hMerge="1" vMerge="1">
-                  <a:txBody>
-                    <a:bodyPr/>
-                    <a:lstStyle/>
-                    <a:p>
-                      <a:endParaRPr lang="en-US"/>
-                    </a:p>
-                  </a:txBody>
-                  <a:tcPr/>
-                </a:tc>
-                <a:tc hMerge="1" vMerge="1">
-                  <a:txBody>
-                    <a:bodyPr/>
-                    <a:lstStyle/>
-                    <a:p>
-                      <a:endParaRPr lang="en-US"/>
-                    </a:p>
-                  </a:txBody>
-                  <a:tcPr/>
                 </a:tc>
                 <a:tc hMerge="1" vMerge="1">
                   <a:txBody>
@@ -7381,7 +6833,7 @@
                     </a:solidFill>
                   </a:tcPr>
                 </a:tc>
-                <a:tc rowSpan="4" gridSpan="2">
+                <a:tc rowSpan="4">
                   <a:txBody>
                     <a:bodyPr/>
                     <a:lstStyle/>
@@ -7435,17 +6887,7 @@
                     </a:lnB>
                   </a:tcPr>
                 </a:tc>
-                <a:tc rowSpan="4" hMerge="1">
-                  <a:txBody>
-                    <a:bodyPr/>
-                    <a:lstStyle/>
-                    <a:p>
-                      <a:endParaRPr lang="en-US"/>
-                    </a:p>
-                  </a:txBody>
-                  <a:tcPr/>
-                </a:tc>
-                <a:tc rowSpan="2" gridSpan="2">
+                <a:tc rowSpan="2">
                   <a:txBody>
                     <a:bodyPr/>
                     <a:lstStyle/>
@@ -7528,16 +6970,6 @@
                     </a:solidFill>
                   </a:tcPr>
                 </a:tc>
-                <a:tc rowSpan="2" hMerge="1">
-                  <a:txBody>
-                    <a:bodyPr/>
-                    <a:lstStyle/>
-                    <a:p>
-                      <a:endParaRPr lang="en-US"/>
-                    </a:p>
-                  </a:txBody>
-                  <a:tcPr/>
-                </a:tc>
                 <a:extLst>
                   <a:ext uri="{0D108BD9-81ED-4DB2-BD59-A6C34878D82A}">
                     <a16:rowId xmlns:a16="http://schemas.microsoft.com/office/drawing/2014/main" val="2105829023"/>
@@ -7747,7 +7179,7 @@
                     </a:lnT>
                   </a:tcPr>
                 </a:tc>
-                <a:tc gridSpan="2" vMerge="1">
+                <a:tc vMerge="1">
                   <a:txBody>
                     <a:bodyPr/>
                     <a:lstStyle/>
@@ -7800,17 +7232,7 @@
                     </a:lnB>
                   </a:tcPr>
                 </a:tc>
-                <a:tc hMerge="1" vMerge="1">
-                  <a:txBody>
-                    <a:bodyPr/>
-                    <a:lstStyle/>
-                    <a:p>
-                      <a:endParaRPr lang="en-US"/>
-                    </a:p>
-                  </a:txBody>
-                  <a:tcPr/>
-                </a:tc>
-                <a:tc gridSpan="2" vMerge="1">
+                <a:tc vMerge="1">
                   <a:txBody>
                     <a:bodyPr/>
                     <a:lstStyle/>
@@ -7860,16 +7282,6 @@
                       <a:tailEnd type="none" w="med" len="med"/>
                     </a:lnB>
                   </a:tcPr>
-                </a:tc>
-                <a:tc hMerge="1" vMerge="1">
-                  <a:txBody>
-                    <a:bodyPr/>
-                    <a:lstStyle/>
-                    <a:p>
-                      <a:endParaRPr lang="en-US"/>
-                    </a:p>
-                  </a:txBody>
-                  <a:tcPr/>
                 </a:tc>
                 <a:extLst>
                   <a:ext uri="{0D108BD9-81ED-4DB2-BD59-A6C34878D82A}">
@@ -8109,7 +7521,7 @@
                     </a:lnB>
                   </a:tcPr>
                 </a:tc>
-                <a:tc gridSpan="2" vMerge="1">
+                <a:tc vMerge="1">
                   <a:txBody>
                     <a:bodyPr/>
                     <a:lstStyle/>
@@ -8162,17 +7574,7 @@
                     </a:lnB>
                   </a:tcPr>
                 </a:tc>
-                <a:tc hMerge="1" vMerge="1">
-                  <a:txBody>
-                    <a:bodyPr/>
-                    <a:lstStyle/>
-                    <a:p>
-                      <a:endParaRPr lang="en-US"/>
-                    </a:p>
-                  </a:txBody>
-                  <a:tcPr/>
-                </a:tc>
-                <a:tc rowSpan="2" gridSpan="2">
+                <a:tc rowSpan="2">
                   <a:txBody>
                     <a:bodyPr/>
                     <a:lstStyle/>
@@ -8213,16 +7615,6 @@
                       <a:tailEnd type="none" w="med" len="med"/>
                     </a:lnB>
                   </a:tcPr>
-                </a:tc>
-                <a:tc rowSpan="2" hMerge="1">
-                  <a:txBody>
-                    <a:bodyPr/>
-                    <a:lstStyle/>
-                    <a:p>
-                      <a:endParaRPr lang="en-US"/>
-                    </a:p>
-                  </a:txBody>
-                  <a:tcPr/>
                 </a:tc>
                 <a:extLst>
                   <a:ext uri="{0D108BD9-81ED-4DB2-BD59-A6C34878D82A}">
@@ -8443,7 +7835,7 @@
                     </a:lnT>
                   </a:tcPr>
                 </a:tc>
-                <a:tc gridSpan="2" vMerge="1">
+                <a:tc vMerge="1">
                   <a:txBody>
                     <a:bodyPr/>
                     <a:lstStyle/>
@@ -8496,17 +7888,7 @@
                     </a:lnB>
                   </a:tcPr>
                 </a:tc>
-                <a:tc hMerge="1" vMerge="1">
-                  <a:txBody>
-                    <a:bodyPr/>
-                    <a:lstStyle/>
-                    <a:p>
-                      <a:endParaRPr lang="en-US"/>
-                    </a:p>
-                  </a:txBody>
-                  <a:tcPr/>
-                </a:tc>
-                <a:tc gridSpan="2" vMerge="1">
+                <a:tc vMerge="1">
                   <a:txBody>
                     <a:bodyPr/>
                     <a:lstStyle/>
@@ -8556,16 +7938,6 @@
                       <a:tailEnd type="none" w="med" len="med"/>
                     </a:lnB>
                   </a:tcPr>
-                </a:tc>
-                <a:tc hMerge="1" vMerge="1">
-                  <a:txBody>
-                    <a:bodyPr/>
-                    <a:lstStyle/>
-                    <a:p>
-                      <a:endParaRPr lang="en-US"/>
-                    </a:p>
-                  </a:txBody>
-                  <a:tcPr/>
                 </a:tc>
                 <a:extLst>
                   <a:ext uri="{0D108BD9-81ED-4DB2-BD59-A6C34878D82A}">
@@ -8842,7 +8214,7 @@
                     </a:solidFill>
                   </a:tcPr>
                 </a:tc>
-                <a:tc rowSpan="4" gridSpan="4">
+                <a:tc rowSpan="4" gridSpan="2">
                   <a:txBody>
                     <a:bodyPr/>
                     <a:lstStyle/>
@@ -8895,16 +8267,6 @@
                       <a:endParaRPr lang="en-US"/>
                     </a:p>
                   </a:txBody>
-                  <a:tcPr/>
-                </a:tc>
-                <a:tc rowSpan="4" hMerge="1">
-                  <a:txBody>
-                    <a:bodyPr/>
-                    <a:lstStyle/>
-                    <a:p>
-                      <a:endParaRPr lang="en-US"/>
-                    </a:p>
-                  </a:txBody>
                   <a:tcPr>
                     <a:lnT w="12700" cap="flat" cmpd="sng" algn="ctr">
                       <a:solidFill>
@@ -8916,16 +8278,6 @@
                       <a:tailEnd type="none" w="med" len="med"/>
                     </a:lnT>
                   </a:tcPr>
-                </a:tc>
-                <a:tc rowSpan="4" hMerge="1">
-                  <a:txBody>
-                    <a:bodyPr/>
-                    <a:lstStyle/>
-                    <a:p>
-                      <a:endParaRPr lang="en-US"/>
-                    </a:p>
-                  </a:txBody>
-                  <a:tcPr/>
                 </a:tc>
                 <a:extLst>
                   <a:ext uri="{0D108BD9-81ED-4DB2-BD59-A6C34878D82A}">
@@ -9244,7 +8596,7 @@
                     </a:lnT>
                   </a:tcPr>
                 </a:tc>
-                <a:tc gridSpan="4" vMerge="1">
+                <a:tc gridSpan="2" vMerge="1">
                   <a:txBody>
                     <a:bodyPr/>
                     <a:lstStyle/>
@@ -9296,26 +8648,6 @@
                       <a:tailEnd type="none" w="med" len="med"/>
                     </a:lnB>
                   </a:tcPr>
-                </a:tc>
-                <a:tc hMerge="1" vMerge="1">
-                  <a:txBody>
-                    <a:bodyPr/>
-                    <a:lstStyle/>
-                    <a:p>
-                      <a:endParaRPr lang="en-US"/>
-                    </a:p>
-                  </a:txBody>
-                  <a:tcPr/>
-                </a:tc>
-                <a:tc hMerge="1" vMerge="1">
-                  <a:txBody>
-                    <a:bodyPr/>
-                    <a:lstStyle/>
-                    <a:p>
-                      <a:endParaRPr lang="en-US"/>
-                    </a:p>
-                  </a:txBody>
-                  <a:tcPr/>
                 </a:tc>
                 <a:tc hMerge="1" vMerge="1">
                   <a:txBody>
@@ -9666,7 +8998,7 @@
                     </a:lnB>
                   </a:tcPr>
                 </a:tc>
-                <a:tc gridSpan="4" vMerge="1">
+                <a:tc gridSpan="2" vMerge="1">
                   <a:txBody>
                     <a:bodyPr/>
                     <a:lstStyle/>
@@ -9718,26 +9050,6 @@
                       <a:tailEnd type="none" w="med" len="med"/>
                     </a:lnB>
                   </a:tcPr>
-                </a:tc>
-                <a:tc hMerge="1" vMerge="1">
-                  <a:txBody>
-                    <a:bodyPr/>
-                    <a:lstStyle/>
-                    <a:p>
-                      <a:endParaRPr lang="en-US"/>
-                    </a:p>
-                  </a:txBody>
-                  <a:tcPr/>
-                </a:tc>
-                <a:tc hMerge="1" vMerge="1">
-                  <a:txBody>
-                    <a:bodyPr/>
-                    <a:lstStyle/>
-                    <a:p>
-                      <a:endParaRPr lang="en-US"/>
-                    </a:p>
-                  </a:txBody>
-                  <a:tcPr/>
                 </a:tc>
                 <a:tc hMerge="1" vMerge="1">
                   <a:txBody>
@@ -10042,7 +9354,7 @@
                     </a:lnT>
                   </a:tcPr>
                 </a:tc>
-                <a:tc gridSpan="4" vMerge="1">
+                <a:tc gridSpan="2" vMerge="1">
                   <a:txBody>
                     <a:bodyPr/>
                     <a:lstStyle/>
@@ -10096,26 +9408,6 @@
                       <a:tailEnd type="none" w="med" len="med"/>
                     </a:lnB>
                   </a:tcPr>
-                </a:tc>
-                <a:tc hMerge="1" vMerge="1">
-                  <a:txBody>
-                    <a:bodyPr/>
-                    <a:lstStyle/>
-                    <a:p>
-                      <a:endParaRPr lang="en-US"/>
-                    </a:p>
-                  </a:txBody>
-                  <a:tcPr/>
-                </a:tc>
-                <a:tc hMerge="1" vMerge="1">
-                  <a:txBody>
-                    <a:bodyPr/>
-                    <a:lstStyle/>
-                    <a:p>
-                      <a:endParaRPr lang="en-US"/>
-                    </a:p>
-                  </a:txBody>
-                  <a:tcPr/>
                 </a:tc>
                 <a:tc hMerge="1" vMerge="1">
                   <a:txBody>
@@ -10413,7 +9705,7 @@
                   </a:txBody>
                   <a:tcPr/>
                 </a:tc>
-                <a:tc gridSpan="4">
+                <a:tc gridSpan="2">
                   <a:txBody>
                     <a:bodyPr/>
                     <a:lstStyle/>
@@ -10472,27 +9764,17 @@
                       <a:endParaRPr lang="en-US"/>
                     </a:p>
                   </a:txBody>
-                  <a:tcPr/>
-                </a:tc>
-                <a:tc hMerge="1">
-                  <a:txBody>
-                    <a:bodyPr/>
-                    <a:lstStyle/>
-                    <a:p>
-                      <a:endParaRPr lang="en-US"/>
-                    </a:p>
-                  </a:txBody>
-                  <a:tcPr/>
-                </a:tc>
-                <a:tc hMerge="1">
-                  <a:txBody>
-                    <a:bodyPr/>
-                    <a:lstStyle/>
-                    <a:p>
-                      <a:endParaRPr lang="en-US"/>
-                    </a:p>
-                  </a:txBody>
-                  <a:tcPr/>
+                  <a:tcPr>
+                    <a:lnL w="12700" cap="flat" cmpd="sng" algn="ctr">
+                      <a:solidFill>
+                        <a:schemeClr val="accent1"/>
+                      </a:solidFill>
+                      <a:prstDash val="solid"/>
+                      <a:round/>
+                      <a:headEnd type="none" w="med" len="med"/>
+                      <a:tailEnd type="none" w="med" len="med"/>
+                    </a:lnL>
+                  </a:tcPr>
                 </a:tc>
                 <a:extLst>
                   <a:ext uri="{0D108BD9-81ED-4DB2-BD59-A6C34878D82A}">

</xml_diff>